<commit_message>
Updated plots, included SOEP practice data which we are free to share, added a reference to the license.
</commit_message>
<xml_diff>
--- a/plots/logit_scale.pptx
+++ b/plots/logit_scale.pptx
@@ -259,7 +259,7 @@
           <a:p>
             <a:fld id="{CD874F49-FEBB-FF42-B278-30C4F47372F7}" type="datetimeFigureOut">
               <a:rPr lang="de-DE" smtClean="0"/>
-              <a:t>05.06.25</a:t>
+              <a:t>22.10.25</a:t>
             </a:fld>
             <a:endParaRPr lang="de-DE"/>
           </a:p>
@@ -457,7 +457,7 @@
           <a:p>
             <a:fld id="{CD874F49-FEBB-FF42-B278-30C4F47372F7}" type="datetimeFigureOut">
               <a:rPr lang="de-DE" smtClean="0"/>
-              <a:t>05.06.25</a:t>
+              <a:t>22.10.25</a:t>
             </a:fld>
             <a:endParaRPr lang="de-DE"/>
           </a:p>
@@ -665,7 +665,7 @@
           <a:p>
             <a:fld id="{CD874F49-FEBB-FF42-B278-30C4F47372F7}" type="datetimeFigureOut">
               <a:rPr lang="de-DE" smtClean="0"/>
-              <a:t>05.06.25</a:t>
+              <a:t>22.10.25</a:t>
             </a:fld>
             <a:endParaRPr lang="de-DE"/>
           </a:p>
@@ -863,7 +863,7 @@
           <a:p>
             <a:fld id="{CD874F49-FEBB-FF42-B278-30C4F47372F7}" type="datetimeFigureOut">
               <a:rPr lang="de-DE" smtClean="0"/>
-              <a:t>05.06.25</a:t>
+              <a:t>22.10.25</a:t>
             </a:fld>
             <a:endParaRPr lang="de-DE"/>
           </a:p>
@@ -1138,7 +1138,7 @@
           <a:p>
             <a:fld id="{CD874F49-FEBB-FF42-B278-30C4F47372F7}" type="datetimeFigureOut">
               <a:rPr lang="de-DE" smtClean="0"/>
-              <a:t>05.06.25</a:t>
+              <a:t>22.10.25</a:t>
             </a:fld>
             <a:endParaRPr lang="de-DE"/>
           </a:p>
@@ -1403,7 +1403,7 @@
           <a:p>
             <a:fld id="{CD874F49-FEBB-FF42-B278-30C4F47372F7}" type="datetimeFigureOut">
               <a:rPr lang="de-DE" smtClean="0"/>
-              <a:t>05.06.25</a:t>
+              <a:t>22.10.25</a:t>
             </a:fld>
             <a:endParaRPr lang="de-DE"/>
           </a:p>
@@ -1815,7 +1815,7 @@
           <a:p>
             <a:fld id="{CD874F49-FEBB-FF42-B278-30C4F47372F7}" type="datetimeFigureOut">
               <a:rPr lang="de-DE" smtClean="0"/>
-              <a:t>05.06.25</a:t>
+              <a:t>22.10.25</a:t>
             </a:fld>
             <a:endParaRPr lang="de-DE"/>
           </a:p>
@@ -1956,7 +1956,7 @@
           <a:p>
             <a:fld id="{CD874F49-FEBB-FF42-B278-30C4F47372F7}" type="datetimeFigureOut">
               <a:rPr lang="de-DE" smtClean="0"/>
-              <a:t>05.06.25</a:t>
+              <a:t>22.10.25</a:t>
             </a:fld>
             <a:endParaRPr lang="de-DE"/>
           </a:p>
@@ -2069,7 +2069,7 @@
           <a:p>
             <a:fld id="{CD874F49-FEBB-FF42-B278-30C4F47372F7}" type="datetimeFigureOut">
               <a:rPr lang="de-DE" smtClean="0"/>
-              <a:t>05.06.25</a:t>
+              <a:t>22.10.25</a:t>
             </a:fld>
             <a:endParaRPr lang="de-DE"/>
           </a:p>
@@ -2380,7 +2380,7 @@
           <a:p>
             <a:fld id="{CD874F49-FEBB-FF42-B278-30C4F47372F7}" type="datetimeFigureOut">
               <a:rPr lang="de-DE" smtClean="0"/>
-              <a:t>05.06.25</a:t>
+              <a:t>22.10.25</a:t>
             </a:fld>
             <a:endParaRPr lang="de-DE"/>
           </a:p>
@@ -2668,7 +2668,7 @@
           <a:p>
             <a:fld id="{CD874F49-FEBB-FF42-B278-30C4F47372F7}" type="datetimeFigureOut">
               <a:rPr lang="de-DE" smtClean="0"/>
-              <a:t>05.06.25</a:t>
+              <a:t>22.10.25</a:t>
             </a:fld>
             <a:endParaRPr lang="de-DE"/>
           </a:p>
@@ -2909,7 +2909,7 @@
           <a:p>
             <a:fld id="{CD874F49-FEBB-FF42-B278-30C4F47372F7}" type="datetimeFigureOut">
               <a:rPr lang="de-DE" smtClean="0"/>
-              <a:t>05.06.25</a:t>
+              <a:t>22.10.25</a:t>
             </a:fld>
             <a:endParaRPr lang="de-DE"/>
           </a:p>
@@ -3431,7 +3431,27 @@
                 <a:latin typeface="Helvetica" pitchFamily="2" charset="0"/>
                 <a:cs typeface="Consolas" panose="020B0609020204030204" pitchFamily="49" charset="0"/>
               </a:rPr>
-              <a:t> 0.98 – 0.50 =  0.48 </a:t>
+              <a:t> 0.98 – 0.50 =  0.48, </a:t>
+            </a:r>
+            <a:r>
+              <a:rPr lang="de-DE" sz="1100" dirty="0" err="1">
+                <a:solidFill>
+                  <a:srgbClr val="55B2E7"/>
+                </a:solidFill>
+                <a:latin typeface="Helvetica" pitchFamily="2" charset="0"/>
+                <a:cs typeface="Consolas" panose="020B0609020204030204" pitchFamily="49" charset="0"/>
+              </a:rPr>
+              <a:t>or</a:t>
+            </a:r>
+            <a:r>
+              <a:rPr lang="de-DE" sz="1100" dirty="0">
+                <a:solidFill>
+                  <a:srgbClr val="55B2E7"/>
+                </a:solidFill>
+                <a:latin typeface="Helvetica" pitchFamily="2" charset="0"/>
+                <a:cs typeface="Consolas" panose="020B0609020204030204" pitchFamily="49" charset="0"/>
+              </a:rPr>
+              <a:t> 48 </a:t>
             </a:r>
             <a:r>
               <a:rPr lang="de-DE" sz="1100" dirty="0" err="1">

</xml_diff>